<commit_message>
Sandoz Q3 2026: add CEO quote from the opening of the earnings call
Co-Authored-By: Claude Opus 5.5 <noreply@anthropic.com>
Claude-Session: https://claude.ai/code/session_0194roGR9gj46kR1yhWUsVf3
</commit_message>
<xml_diff>
--- a/reports/SDZ_Q3_2026/Earnings_Update_SDZ_Q32026.pptx
+++ b/reports/SDZ_Q3_2026/Earnings_Update_SDZ_Q32026.pptx
@@ -1301,13 +1301,119 @@
       </p:sp>
       <p:sp>
         <p:nvSpPr>
-          <p:cNvPr id="9" name="Text 5"/>
-          <p:cNvSpPr txBox="1"/>
+          <p:cNvPr id="9" name="Shape 5"/>
+          <p:cNvSpPr/>
           <p:nvPr/>
         </p:nvSpPr>
         <p:spPr>
           <a:xfrm>
             <a:off x="539496" y="1602994"/>
+            <a:ext cx="42977" cy="536067"/>
+          </a:xfrm>
+          <a:prstGeom prst="rect">
+            <a:avLst/>
+          </a:prstGeom>
+          <a:solidFill>
+            <a:srgbClr val="FF6C0E"/>
+          </a:solidFill>
+          <a:ln w="12700">
+            <a:solidFill>
+              <a:srgbClr val="FF6C0E"/>
+            </a:solidFill>
+            <a:prstDash val="solid"/>
+          </a:ln>
+        </p:spPr>
+      </p:sp>
+      <p:sp>
+        <p:nvSpPr>
+          <p:cNvPr id="10" name="Text 6"/>
+          <p:cNvSpPr txBox="1"/>
+          <p:nvPr/>
+        </p:nvSpPr>
+        <p:spPr>
+          <a:xfrm>
+            <a:off x="722376" y="1621282"/>
+            <a:ext cx="6300216" cy="298323"/>
+          </a:xfrm>
+          <a:prstGeom prst="rect">
+            <a:avLst/>
+          </a:prstGeom>
+          <a:noFill/>
+          <a:ln/>
+        </p:spPr>
+        <p:txBody>
+          <a:bodyPr wrap="square" lIns="0" tIns="0" rIns="0" bIns="0" rtlCol="0" anchor="t"/>
+          <a:lstStyle/>
+          <a:p>
+            <a:pPr indent="0" marL="0">
+              <a:lnSpc>
+                <a:spcPct val="112500"/>
+              </a:lnSpc>
+              <a:buNone/>
+            </a:pPr>
+            <a:r>
+              <a:rPr lang="en-US" sz="870" b="1" dirty="0">
+                <a:solidFill>
+                  <a:srgbClr val="202945"/>
+                </a:solidFill>
+                <a:latin typeface="Nunito" pitchFamily="34" charset="0"/>
+                <a:ea typeface="Nunito" pitchFamily="34" charset="-122"/>
+                <a:cs typeface="Nunito" pitchFamily="34" charset="-120"/>
+              </a:rPr>
+              <a:t>“Today, we have narrowed our 2026 net sales guidance to 5%–6% and upgraded our core EBITDA margin guidance for the year to 23%–23.5%. We will enter 2027 with strong momentum.”</a:t>
+            </a:r>
+            <a:endParaRPr lang="en-US" sz="870" dirty="0"/>
+          </a:p>
+        </p:txBody>
+      </p:sp>
+      <p:sp>
+        <p:nvSpPr>
+          <p:cNvPr id="11" name="Text 7"/>
+          <p:cNvSpPr txBox="1"/>
+          <p:nvPr/>
+        </p:nvSpPr>
+        <p:spPr>
+          <a:xfrm>
+            <a:off x="722376" y="1956181"/>
+            <a:ext cx="6300216" cy="155448"/>
+          </a:xfrm>
+          <a:prstGeom prst="rect">
+            <a:avLst/>
+          </a:prstGeom>
+          <a:noFill/>
+          <a:ln/>
+        </p:spPr>
+        <p:txBody>
+          <a:bodyPr wrap="square" lIns="0" tIns="0" rIns="0" bIns="0" rtlCol="0" anchor="t"/>
+          <a:lstStyle/>
+          <a:p>
+            <a:pPr indent="0" marL="0">
+              <a:buNone/>
+            </a:pPr>
+            <a:r>
+              <a:rPr lang="en-US" sz="700" b="1" dirty="0">
+                <a:solidFill>
+                  <a:srgbClr val="6B7280"/>
+                </a:solidFill>
+                <a:latin typeface="Nunito" pitchFamily="34" charset="0"/>
+                <a:ea typeface="Nunito" pitchFamily="34" charset="-122"/>
+                <a:cs typeface="Nunito" pitchFamily="34" charset="-120"/>
+              </a:rPr>
+              <a:t>Richard Saynor, CEO, Q3 2026 earnings call, 28 October 2026</a:t>
+            </a:r>
+            <a:endParaRPr lang="en-US" sz="700" dirty="0"/>
+          </a:p>
+        </p:txBody>
+      </p:sp>
+      <p:sp>
+        <p:nvSpPr>
+          <p:cNvPr id="12" name="Text 8"/>
+          <p:cNvSpPr txBox="1"/>
+          <p:nvPr/>
+        </p:nvSpPr>
+        <p:spPr>
+          <a:xfrm>
+            <a:off x="539496" y="2257933"/>
             <a:ext cx="6483096" cy="332080"/>
           </a:xfrm>
           <a:prstGeom prst="rect">
@@ -1343,13 +1449,13 @@
       </p:sp>
       <p:sp>
         <p:nvSpPr>
-          <p:cNvPr id="10" name="Text 6"/>
-          <p:cNvSpPr txBox="1"/>
-          <p:nvPr/>
-        </p:nvSpPr>
-        <p:spPr>
-          <a:xfrm>
-            <a:off x="539496" y="2053946"/>
+          <p:cNvPr id="13" name="Text 9"/>
+          <p:cNvSpPr txBox="1"/>
+          <p:nvPr/>
+        </p:nvSpPr>
+        <p:spPr>
+          <a:xfrm>
+            <a:off x="539496" y="2708885"/>
             <a:ext cx="6483096" cy="219456"/>
           </a:xfrm>
           <a:prstGeom prst="rect">
@@ -1382,13 +1488,13 @@
       </p:sp>
       <p:sp>
         <p:nvSpPr>
-          <p:cNvPr id="11" name="Text 7"/>
-          <p:cNvSpPr txBox="1"/>
-          <p:nvPr/>
-        </p:nvSpPr>
-        <p:spPr>
-          <a:xfrm>
-            <a:off x="539496" y="2314550"/>
+          <p:cNvPr id="14" name="Text 10"/>
+          <p:cNvSpPr txBox="1"/>
+          <p:nvPr/>
+        </p:nvSpPr>
+        <p:spPr>
+          <a:xfrm>
+            <a:off x="539496" y="2969489"/>
             <a:ext cx="576072" cy="156896"/>
           </a:xfrm>
           <a:prstGeom prst="rect">
@@ -1421,13 +1527,13 @@
       </p:sp>
       <p:sp>
         <p:nvSpPr>
-          <p:cNvPr id="12" name="Text 8"/>
-          <p:cNvSpPr txBox="1"/>
-          <p:nvPr/>
-        </p:nvSpPr>
-        <p:spPr>
-          <a:xfrm>
-            <a:off x="1133856" y="2291690"/>
+          <p:cNvPr id="15" name="Text 11"/>
+          <p:cNvSpPr txBox="1"/>
+          <p:nvPr/>
+        </p:nvSpPr>
+        <p:spPr>
+          <a:xfrm>
+            <a:off x="1133856" y="2946629"/>
             <a:ext cx="5888736" cy="156896"/>
           </a:xfrm>
           <a:prstGeom prst="rect">
@@ -1463,13 +1569,13 @@
       </p:sp>
       <p:sp>
         <p:nvSpPr>
-          <p:cNvPr id="13" name="Text 9"/>
-          <p:cNvSpPr txBox="1"/>
-          <p:nvPr/>
-        </p:nvSpPr>
-        <p:spPr>
-          <a:xfrm>
-            <a:off x="539496" y="2517165"/>
+          <p:cNvPr id="16" name="Text 12"/>
+          <p:cNvSpPr txBox="1"/>
+          <p:nvPr/>
+        </p:nvSpPr>
+        <p:spPr>
+          <a:xfrm>
+            <a:off x="539496" y="3172104"/>
             <a:ext cx="576072" cy="156896"/>
           </a:xfrm>
           <a:prstGeom prst="rect">
@@ -1502,13 +1608,13 @@
       </p:sp>
       <p:sp>
         <p:nvSpPr>
-          <p:cNvPr id="14" name="Text 10"/>
-          <p:cNvSpPr txBox="1"/>
-          <p:nvPr/>
-        </p:nvSpPr>
-        <p:spPr>
-          <a:xfrm>
-            <a:off x="1133856" y="2494305"/>
+          <p:cNvPr id="17" name="Text 13"/>
+          <p:cNvSpPr txBox="1"/>
+          <p:nvPr/>
+        </p:nvSpPr>
+        <p:spPr>
+          <a:xfrm>
+            <a:off x="1133856" y="3149244"/>
             <a:ext cx="5888736" cy="156896"/>
           </a:xfrm>
           <a:prstGeom prst="rect">
@@ -1544,13 +1650,13 @@
       </p:sp>
       <p:sp>
         <p:nvSpPr>
-          <p:cNvPr id="15" name="Text 11"/>
-          <p:cNvSpPr txBox="1"/>
-          <p:nvPr/>
-        </p:nvSpPr>
-        <p:spPr>
-          <a:xfrm>
-            <a:off x="539496" y="2719781"/>
+          <p:cNvPr id="18" name="Text 14"/>
+          <p:cNvSpPr txBox="1"/>
+          <p:nvPr/>
+        </p:nvSpPr>
+        <p:spPr>
+          <a:xfrm>
+            <a:off x="539496" y="3374720"/>
             <a:ext cx="576072" cy="156896"/>
           </a:xfrm>
           <a:prstGeom prst="rect">
@@ -1583,13 +1689,13 @@
       </p:sp>
       <p:sp>
         <p:nvSpPr>
-          <p:cNvPr id="16" name="Text 12"/>
-          <p:cNvSpPr txBox="1"/>
-          <p:nvPr/>
-        </p:nvSpPr>
-        <p:spPr>
-          <a:xfrm>
-            <a:off x="1133856" y="2696921"/>
+          <p:cNvPr id="19" name="Text 15"/>
+          <p:cNvSpPr txBox="1"/>
+          <p:nvPr/>
+        </p:nvSpPr>
+        <p:spPr>
+          <a:xfrm>
+            <a:off x="1133856" y="3351860"/>
             <a:ext cx="5888736" cy="156896"/>
           </a:xfrm>
           <a:prstGeom prst="rect">
@@ -1625,13 +1731,13 @@
       </p:sp>
       <p:sp>
         <p:nvSpPr>
-          <p:cNvPr id="17" name="Text 13"/>
-          <p:cNvSpPr txBox="1"/>
-          <p:nvPr/>
-        </p:nvSpPr>
-        <p:spPr>
-          <a:xfrm>
-            <a:off x="539496" y="2922397"/>
+          <p:cNvPr id="20" name="Text 16"/>
+          <p:cNvSpPr txBox="1"/>
+          <p:nvPr/>
+        </p:nvSpPr>
+        <p:spPr>
+          <a:xfrm>
+            <a:off x="539496" y="3577336"/>
             <a:ext cx="576072" cy="156896"/>
           </a:xfrm>
           <a:prstGeom prst="rect">
@@ -1664,13 +1770,13 @@
       </p:sp>
       <p:sp>
         <p:nvSpPr>
-          <p:cNvPr id="18" name="Text 14"/>
-          <p:cNvSpPr txBox="1"/>
-          <p:nvPr/>
-        </p:nvSpPr>
-        <p:spPr>
-          <a:xfrm>
-            <a:off x="1133856" y="2899537"/>
+          <p:cNvPr id="21" name="Text 17"/>
+          <p:cNvSpPr txBox="1"/>
+          <p:nvPr/>
+        </p:nvSpPr>
+        <p:spPr>
+          <a:xfrm>
+            <a:off x="1133856" y="3554476"/>
             <a:ext cx="5888736" cy="156896"/>
           </a:xfrm>
           <a:prstGeom prst="rect">
@@ -1706,13 +1812,13 @@
       </p:sp>
       <p:sp>
         <p:nvSpPr>
-          <p:cNvPr id="19" name="Shape 15"/>
+          <p:cNvPr id="22" name="Shape 18"/>
           <p:cNvSpPr/>
           <p:nvPr/>
         </p:nvSpPr>
         <p:spPr>
           <a:xfrm>
-            <a:off x="539496" y="3184449"/>
+            <a:off x="539496" y="3839388"/>
             <a:ext cx="6483096" cy="640080"/>
           </a:xfrm>
           <a:prstGeom prst="rect">
@@ -1731,13 +1837,13 @@
       </p:sp>
       <p:sp>
         <p:nvSpPr>
-          <p:cNvPr id="20" name="Text 16"/>
-          <p:cNvSpPr txBox="1"/>
-          <p:nvPr/>
-        </p:nvSpPr>
-        <p:spPr>
-          <a:xfrm>
-            <a:off x="649224" y="3257601"/>
+          <p:cNvPr id="23" name="Text 19"/>
+          <p:cNvSpPr txBox="1"/>
+          <p:nvPr/>
+        </p:nvSpPr>
+        <p:spPr>
+          <a:xfrm>
+            <a:off x="649224" y="3912540"/>
             <a:ext cx="1437894" cy="137160"/>
           </a:xfrm>
           <a:prstGeom prst="rect">
@@ -1770,13 +1876,13 @@
       </p:sp>
       <p:sp>
         <p:nvSpPr>
-          <p:cNvPr id="21" name="Text 17"/>
-          <p:cNvSpPr txBox="1"/>
-          <p:nvPr/>
-        </p:nvSpPr>
-        <p:spPr>
-          <a:xfrm>
-            <a:off x="649224" y="3394761"/>
+          <p:cNvPr id="24" name="Text 20"/>
+          <p:cNvSpPr txBox="1"/>
+          <p:nvPr/>
+        </p:nvSpPr>
+        <p:spPr>
+          <a:xfrm>
+            <a:off x="649224" y="4049700"/>
             <a:ext cx="1437894" cy="201168"/>
           </a:xfrm>
           <a:prstGeom prst="rect">
@@ -1809,13 +1915,13 @@
       </p:sp>
       <p:sp>
         <p:nvSpPr>
-          <p:cNvPr id="22" name="Text 18"/>
-          <p:cNvSpPr txBox="1"/>
-          <p:nvPr/>
-        </p:nvSpPr>
-        <p:spPr>
-          <a:xfrm>
-            <a:off x="649224" y="3605073"/>
+          <p:cNvPr id="25" name="Text 21"/>
+          <p:cNvSpPr txBox="1"/>
+          <p:nvPr/>
+        </p:nvSpPr>
+        <p:spPr>
+          <a:xfrm>
+            <a:off x="649224" y="4260012"/>
             <a:ext cx="1437894" cy="137160"/>
           </a:xfrm>
           <a:prstGeom prst="rect">
@@ -1848,13 +1954,13 @@
       </p:sp>
       <p:sp>
         <p:nvSpPr>
-          <p:cNvPr id="23" name="Shape 19"/>
+          <p:cNvPr id="26" name="Shape 22"/>
           <p:cNvSpPr/>
           <p:nvPr/>
         </p:nvSpPr>
         <p:spPr>
           <a:xfrm>
-            <a:off x="2160270" y="3184449"/>
+            <a:off x="2160270" y="3839388"/>
             <a:ext cx="0" cy="640080"/>
           </a:xfrm>
           <a:prstGeom prst="line">
@@ -1871,13 +1977,13 @@
       </p:sp>
       <p:sp>
         <p:nvSpPr>
-          <p:cNvPr id="24" name="Text 20"/>
-          <p:cNvSpPr txBox="1"/>
-          <p:nvPr/>
-        </p:nvSpPr>
-        <p:spPr>
-          <a:xfrm>
-            <a:off x="2269998" y="3257601"/>
+          <p:cNvPr id="27" name="Text 23"/>
+          <p:cNvSpPr txBox="1"/>
+          <p:nvPr/>
+        </p:nvSpPr>
+        <p:spPr>
+          <a:xfrm>
+            <a:off x="2269998" y="3912540"/>
             <a:ext cx="1437894" cy="137160"/>
           </a:xfrm>
           <a:prstGeom prst="rect">
@@ -1910,13 +2016,13 @@
       </p:sp>
       <p:sp>
         <p:nvSpPr>
-          <p:cNvPr id="25" name="Text 21"/>
-          <p:cNvSpPr txBox="1"/>
-          <p:nvPr/>
-        </p:nvSpPr>
-        <p:spPr>
-          <a:xfrm>
-            <a:off x="2269998" y="3394761"/>
+          <p:cNvPr id="28" name="Text 24"/>
+          <p:cNvSpPr txBox="1"/>
+          <p:nvPr/>
+        </p:nvSpPr>
+        <p:spPr>
+          <a:xfrm>
+            <a:off x="2269998" y="4049700"/>
             <a:ext cx="1437894" cy="201168"/>
           </a:xfrm>
           <a:prstGeom prst="rect">
@@ -1949,13 +2055,13 @@
       </p:sp>
       <p:sp>
         <p:nvSpPr>
-          <p:cNvPr id="26" name="Text 22"/>
-          <p:cNvSpPr txBox="1"/>
-          <p:nvPr/>
-        </p:nvSpPr>
-        <p:spPr>
-          <a:xfrm>
-            <a:off x="2269998" y="3605073"/>
+          <p:cNvPr id="29" name="Text 25"/>
+          <p:cNvSpPr txBox="1"/>
+          <p:nvPr/>
+        </p:nvSpPr>
+        <p:spPr>
+          <a:xfrm>
+            <a:off x="2269998" y="4260012"/>
             <a:ext cx="1437894" cy="137160"/>
           </a:xfrm>
           <a:prstGeom prst="rect">
@@ -1988,13 +2094,13 @@
       </p:sp>
       <p:sp>
         <p:nvSpPr>
-          <p:cNvPr id="27" name="Shape 23"/>
+          <p:cNvPr id="30" name="Shape 26"/>
           <p:cNvSpPr/>
           <p:nvPr/>
         </p:nvSpPr>
         <p:spPr>
           <a:xfrm>
-            <a:off x="3781044" y="3184449"/>
+            <a:off x="3781044" y="3839388"/>
             <a:ext cx="0" cy="640080"/>
           </a:xfrm>
           <a:prstGeom prst="line">
@@ -2011,13 +2117,13 @@
       </p:sp>
       <p:sp>
         <p:nvSpPr>
-          <p:cNvPr id="28" name="Text 24"/>
-          <p:cNvSpPr txBox="1"/>
-          <p:nvPr/>
-        </p:nvSpPr>
-        <p:spPr>
-          <a:xfrm>
-            <a:off x="3890772" y="3257601"/>
+          <p:cNvPr id="31" name="Text 27"/>
+          <p:cNvSpPr txBox="1"/>
+          <p:nvPr/>
+        </p:nvSpPr>
+        <p:spPr>
+          <a:xfrm>
+            <a:off x="3890772" y="3912540"/>
             <a:ext cx="1437894" cy="137160"/>
           </a:xfrm>
           <a:prstGeom prst="rect">
@@ -2050,13 +2156,13 @@
       </p:sp>
       <p:sp>
         <p:nvSpPr>
-          <p:cNvPr id="29" name="Text 25"/>
-          <p:cNvSpPr txBox="1"/>
-          <p:nvPr/>
-        </p:nvSpPr>
-        <p:spPr>
-          <a:xfrm>
-            <a:off x="3890772" y="3394761"/>
+          <p:cNvPr id="32" name="Text 28"/>
+          <p:cNvSpPr txBox="1"/>
+          <p:nvPr/>
+        </p:nvSpPr>
+        <p:spPr>
+          <a:xfrm>
+            <a:off x="3890772" y="4049700"/>
             <a:ext cx="1437894" cy="201168"/>
           </a:xfrm>
           <a:prstGeom prst="rect">
@@ -2089,13 +2195,13 @@
       </p:sp>
       <p:sp>
         <p:nvSpPr>
-          <p:cNvPr id="30" name="Text 26"/>
-          <p:cNvSpPr txBox="1"/>
-          <p:nvPr/>
-        </p:nvSpPr>
-        <p:spPr>
-          <a:xfrm>
-            <a:off x="3890772" y="3605073"/>
+          <p:cNvPr id="33" name="Text 29"/>
+          <p:cNvSpPr txBox="1"/>
+          <p:nvPr/>
+        </p:nvSpPr>
+        <p:spPr>
+          <a:xfrm>
+            <a:off x="3890772" y="4260012"/>
             <a:ext cx="1437894" cy="137160"/>
           </a:xfrm>
           <a:prstGeom prst="rect">
@@ -2128,13 +2234,13 @@
       </p:sp>
       <p:sp>
         <p:nvSpPr>
-          <p:cNvPr id="31" name="Shape 27"/>
+          <p:cNvPr id="34" name="Shape 30"/>
           <p:cNvSpPr/>
           <p:nvPr/>
         </p:nvSpPr>
         <p:spPr>
           <a:xfrm>
-            <a:off x="5401818" y="3184449"/>
+            <a:off x="5401818" y="3839388"/>
             <a:ext cx="0" cy="640080"/>
           </a:xfrm>
           <a:prstGeom prst="line">
@@ -2151,13 +2257,13 @@
       </p:sp>
       <p:sp>
         <p:nvSpPr>
-          <p:cNvPr id="32" name="Text 28"/>
-          <p:cNvSpPr txBox="1"/>
-          <p:nvPr/>
-        </p:nvSpPr>
-        <p:spPr>
-          <a:xfrm>
-            <a:off x="5511546" y="3257601"/>
+          <p:cNvPr id="35" name="Text 31"/>
+          <p:cNvSpPr txBox="1"/>
+          <p:nvPr/>
+        </p:nvSpPr>
+        <p:spPr>
+          <a:xfrm>
+            <a:off x="5511546" y="3912540"/>
             <a:ext cx="1437894" cy="137160"/>
           </a:xfrm>
           <a:prstGeom prst="rect">
@@ -2190,13 +2296,13 @@
       </p:sp>
       <p:sp>
         <p:nvSpPr>
-          <p:cNvPr id="33" name="Text 29"/>
-          <p:cNvSpPr txBox="1"/>
-          <p:nvPr/>
-        </p:nvSpPr>
-        <p:spPr>
-          <a:xfrm>
-            <a:off x="5511546" y="3394761"/>
+          <p:cNvPr id="36" name="Text 32"/>
+          <p:cNvSpPr txBox="1"/>
+          <p:nvPr/>
+        </p:nvSpPr>
+        <p:spPr>
+          <a:xfrm>
+            <a:off x="5511546" y="4049700"/>
             <a:ext cx="1437894" cy="201168"/>
           </a:xfrm>
           <a:prstGeom prst="rect">
@@ -2229,13 +2335,13 @@
       </p:sp>
       <p:sp>
         <p:nvSpPr>
-          <p:cNvPr id="34" name="Text 30"/>
-          <p:cNvSpPr txBox="1"/>
-          <p:nvPr/>
-        </p:nvSpPr>
-        <p:spPr>
-          <a:xfrm>
-            <a:off x="5511546" y="3605073"/>
+          <p:cNvPr id="37" name="Text 33"/>
+          <p:cNvSpPr txBox="1"/>
+          <p:nvPr/>
+        </p:nvSpPr>
+        <p:spPr>
+          <a:xfrm>
+            <a:off x="5511546" y="4260012"/>
             <a:ext cx="1437894" cy="137160"/>
           </a:xfrm>
           <a:prstGeom prst="rect">
@@ -2268,13 +2374,13 @@
       </p:sp>
       <p:sp>
         <p:nvSpPr>
-          <p:cNvPr id="35" name="Text 31"/>
-          <p:cNvSpPr txBox="1"/>
-          <p:nvPr/>
-        </p:nvSpPr>
-        <p:spPr>
-          <a:xfrm>
-            <a:off x="539496" y="3943401"/>
+          <p:cNvPr id="38" name="Text 34"/>
+          <p:cNvSpPr txBox="1"/>
+          <p:nvPr/>
+        </p:nvSpPr>
+        <p:spPr>
+          <a:xfrm>
+            <a:off x="539496" y="4598340"/>
             <a:ext cx="6483096" cy="219456"/>
           </a:xfrm>
           <a:prstGeom prst="rect">
@@ -2307,13 +2413,13 @@
       </p:sp>
       <p:sp>
         <p:nvSpPr>
-          <p:cNvPr id="36" name="Text 32"/>
-          <p:cNvSpPr txBox="1"/>
-          <p:nvPr/>
-        </p:nvSpPr>
-        <p:spPr>
-          <a:xfrm>
-            <a:off x="539496" y="4190289"/>
+          <p:cNvPr id="39" name="Text 35"/>
+          <p:cNvSpPr txBox="1"/>
+          <p:nvPr/>
+        </p:nvSpPr>
+        <p:spPr>
+          <a:xfrm>
+            <a:off x="539496" y="4845228"/>
             <a:ext cx="6483096" cy="488975"/>
           </a:xfrm>
           <a:prstGeom prst="rect">
@@ -2349,13 +2455,13 @@
       </p:sp>
       <p:sp>
         <p:nvSpPr>
-          <p:cNvPr id="37" name="Text 33"/>
-          <p:cNvSpPr txBox="1"/>
-          <p:nvPr/>
-        </p:nvSpPr>
-        <p:spPr>
-          <a:xfrm>
-            <a:off x="539496" y="4758817"/>
+          <p:cNvPr id="40" name="Text 36"/>
+          <p:cNvSpPr txBox="1"/>
+          <p:nvPr/>
+        </p:nvSpPr>
+        <p:spPr>
+          <a:xfrm>
+            <a:off x="539496" y="5413756"/>
             <a:ext cx="6483096" cy="173736"/>
           </a:xfrm>
           <a:prstGeom prst="rect">
@@ -2402,13 +2508,13 @@
       </p:sp>
       <p:sp>
         <p:nvSpPr>
-          <p:cNvPr id="38" name="Text 34"/>
-          <p:cNvSpPr txBox="1"/>
-          <p:nvPr/>
-        </p:nvSpPr>
-        <p:spPr>
-          <a:xfrm>
-            <a:off x="539496" y="4932553"/>
+          <p:cNvPr id="41" name="Text 37"/>
+          <p:cNvSpPr txBox="1"/>
+          <p:nvPr/>
+        </p:nvSpPr>
+        <p:spPr>
+          <a:xfrm>
+            <a:off x="539496" y="5587492"/>
             <a:ext cx="6483096" cy="115570"/>
           </a:xfrm>
           <a:prstGeom prst="rect">
@@ -2444,7 +2550,7 @@
       </p:sp>
       <p:pic>
         <p:nvPicPr>
-          <p:cNvPr id="39" name="Image 2" descr="/home/claude/sdz/c1_crop.png">    </p:cNvPr>
+          <p:cNvPr id="42" name="Image 2" descr="/home/claude/sdz/c1_crop.png">    </p:cNvPr>
           <p:cNvPicPr>
             <a:picLocks noChangeAspect="1"/>
           </p:cNvPicPr>
@@ -2458,7 +2564,7 @@
         </p:blipFill>
         <p:spPr>
           <a:xfrm>
-            <a:off x="1511960" y="5093843"/>
+            <a:off x="1511960" y="5748782"/>
             <a:ext cx="4538167" cy="1415908"/>
           </a:xfrm>
           <a:prstGeom prst="rect">
@@ -2468,13 +2574,13 @@
       </p:pic>
       <p:sp>
         <p:nvSpPr>
-          <p:cNvPr id="40" name="Text 35"/>
-          <p:cNvSpPr txBox="1"/>
-          <p:nvPr/>
-        </p:nvSpPr>
-        <p:spPr>
-          <a:xfrm>
-            <a:off x="539496" y="6564615"/>
+          <p:cNvPr id="43" name="Text 38"/>
+          <p:cNvSpPr txBox="1"/>
+          <p:nvPr/>
+        </p:nvSpPr>
+        <p:spPr>
+          <a:xfrm>
+            <a:off x="539496" y="7219554"/>
             <a:ext cx="6483096" cy="488975"/>
           </a:xfrm>
           <a:prstGeom prst="rect">
@@ -2510,13 +2616,13 @@
       </p:sp>
       <p:sp>
         <p:nvSpPr>
-          <p:cNvPr id="41" name="Text 36"/>
-          <p:cNvSpPr txBox="1"/>
-          <p:nvPr/>
-        </p:nvSpPr>
-        <p:spPr>
-          <a:xfrm>
-            <a:off x="539496" y="7169719"/>
+          <p:cNvPr id="44" name="Text 39"/>
+          <p:cNvSpPr txBox="1"/>
+          <p:nvPr/>
+        </p:nvSpPr>
+        <p:spPr>
+          <a:xfrm>
+            <a:off x="539496" y="7824658"/>
             <a:ext cx="6483096" cy="219456"/>
           </a:xfrm>
           <a:prstGeom prst="rect">
@@ -2549,13 +2655,13 @@
       </p:sp>
       <p:sp>
         <p:nvSpPr>
-          <p:cNvPr id="42" name="Text 37"/>
-          <p:cNvSpPr txBox="1"/>
-          <p:nvPr/>
-        </p:nvSpPr>
-        <p:spPr>
-          <a:xfrm>
-            <a:off x="539496" y="7416607"/>
+          <p:cNvPr id="45" name="Text 40"/>
+          <p:cNvSpPr txBox="1"/>
+          <p:nvPr/>
+        </p:nvSpPr>
+        <p:spPr>
+          <a:xfrm>
+            <a:off x="539496" y="8071546"/>
             <a:ext cx="6483096" cy="802767"/>
           </a:xfrm>
           <a:prstGeom prst="rect">
@@ -2591,13 +2697,13 @@
       </p:sp>
       <p:sp>
         <p:nvSpPr>
-          <p:cNvPr id="43" name="Shape 38"/>
+          <p:cNvPr id="46" name="Shape 41"/>
           <p:cNvSpPr/>
           <p:nvPr/>
         </p:nvSpPr>
         <p:spPr>
           <a:xfrm>
-            <a:off x="3781044" y="8335503"/>
+            <a:off x="3781044" y="8990442"/>
             <a:ext cx="0" cy="828751"/>
           </a:xfrm>
           <a:prstGeom prst="line">
@@ -2614,13 +2720,13 @@
       </p:sp>
       <p:sp>
         <p:nvSpPr>
-          <p:cNvPr id="44" name="Text 39"/>
-          <p:cNvSpPr txBox="1"/>
-          <p:nvPr/>
-        </p:nvSpPr>
-        <p:spPr>
-          <a:xfrm>
-            <a:off x="539496" y="8335503"/>
+          <p:cNvPr id="47" name="Text 42"/>
+          <p:cNvSpPr txBox="1"/>
+          <p:nvPr/>
+        </p:nvSpPr>
+        <p:spPr>
+          <a:xfrm>
+            <a:off x="539496" y="8990442"/>
             <a:ext cx="3058668" cy="155448"/>
           </a:xfrm>
           <a:prstGeom prst="rect">
@@ -2653,13 +2759,13 @@
       </p:sp>
       <p:sp>
         <p:nvSpPr>
-          <p:cNvPr id="45" name="Text 40"/>
-          <p:cNvSpPr txBox="1"/>
-          <p:nvPr/>
-        </p:nvSpPr>
-        <p:spPr>
-          <a:xfrm>
-            <a:off x="539496" y="8527527"/>
+          <p:cNvPr id="48" name="Text 43"/>
+          <p:cNvSpPr txBox="1"/>
+          <p:nvPr/>
+        </p:nvSpPr>
+        <p:spPr>
+          <a:xfrm>
+            <a:off x="539496" y="9182466"/>
             <a:ext cx="3058668" cy="627583"/>
           </a:xfrm>
           <a:prstGeom prst="rect">
@@ -2695,13 +2801,13 @@
       </p:sp>
       <p:sp>
         <p:nvSpPr>
-          <p:cNvPr id="46" name="Text 41"/>
-          <p:cNvSpPr txBox="1"/>
-          <p:nvPr/>
-        </p:nvSpPr>
-        <p:spPr>
-          <a:xfrm>
-            <a:off x="3963924" y="8335503"/>
+          <p:cNvPr id="49" name="Text 44"/>
+          <p:cNvSpPr txBox="1"/>
+          <p:nvPr/>
+        </p:nvSpPr>
+        <p:spPr>
+          <a:xfrm>
+            <a:off x="3963924" y="8990442"/>
             <a:ext cx="3058668" cy="155448"/>
           </a:xfrm>
           <a:prstGeom prst="rect">
@@ -2734,13 +2840,13 @@
       </p:sp>
       <p:sp>
         <p:nvSpPr>
-          <p:cNvPr id="47" name="Text 42"/>
-          <p:cNvSpPr txBox="1"/>
-          <p:nvPr/>
-        </p:nvSpPr>
-        <p:spPr>
-          <a:xfrm>
-            <a:off x="3963924" y="8527527"/>
+          <p:cNvPr id="50" name="Text 45"/>
+          <p:cNvSpPr txBox="1"/>
+          <p:nvPr/>
+        </p:nvSpPr>
+        <p:spPr>
+          <a:xfrm>
+            <a:off x="3963924" y="9182466"/>
             <a:ext cx="3058668" cy="627583"/>
           </a:xfrm>
           <a:prstGeom prst="rect">
@@ -3580,7 +3686,7 @@
                 <a:ea typeface="Nunito" pitchFamily="34" charset="-122"/>
                 <a:cs typeface="Nunito" pitchFamily="34" charset="-120"/>
               </a:rPr>
-              <a:t> Source: Syz Research, Bloomberg, company filings, Sandoz results release of 28 October 2026, Finanz und Wirtschaft and AWP of 28 October 2026, analyst research notes of 16 and 28 October 2026</a:t>
+              <a:t> Source: Syz Research, Bloomberg, company filings, Sandoz results release and earnings call of 28 October 2026, Finanz und Wirtschaft and AWP of 28 October 2026, analyst research notes of 16 and 28 October 2026</a:t>
             </a:r>
             <a:endParaRPr lang="en-US" sz="700" dirty="0"/>
           </a:p>

</xml_diff>

<commit_message>
Sandoz Q3 2026: rebuild Chart 2 from the updated Bloomberg export
New export (SANDOZ_2): 28 Oct price CHF 79.66, reaction -3.0%, forward
P/E 21.6x vs. a 15.5x average; valuation, reaction and EPS figures in the
text updated to match. EPS axis gets 2.5 to 4.0 half steps.

Co-Authored-By: Claude Opus 5.5 <noreply@anthropic.com>
Claude-Session: https://claude.ai/code/session_0194roGR9gj46kR1yhWUsVf3
</commit_message>
<xml_diff>
--- a/reports/SDZ_Q3_2026/Earnings_Update_SDZ_Q32026.pptx
+++ b/reports/SDZ_Q3_2026/Earnings_Update_SDZ_Q32026.pptx
@@ -1642,7 +1642,7 @@
                 <a:ea typeface="Nunito" pitchFamily="34" charset="-122"/>
                 <a:cs typeface="Nunito" pitchFamily="34" charset="-120"/>
               </a:rPr>
-              <a:t>Shares fell 4.0% on 28 October from a record close, after a 42% gain this year.</a:t>
+              <a:t>Shares fell 3.0% on 28 October, two days after a record close and a 42% gain this year.</a:t>
             </a:r>
             <a:endParaRPr lang="en-US" sz="870" dirty="0"/>
           </a:p>
@@ -1804,7 +1804,7 @@
                 <a:ea typeface="Nunito" pitchFamily="34" charset="-122"/>
                 <a:cs typeface="Nunito" pitchFamily="34" charset="-120"/>
               </a:rPr>
-              <a:t>23.3x forward earnings, 38% above the average since the 2023 listing, after a 23% rise since August.</a:t>
+              <a:t>21.6x forward earnings, 39% above the average since the 2023 listing, after a 24% rise since August.</a:t>
             </a:r>
             <a:endParaRPr lang="en-US" sz="870" dirty="0"/>
           </a:p>
@@ -2447,7 +2447,7 @@
                 <a:ea typeface="Nunito" pitchFamily="34" charset="-122"/>
                 <a:cs typeface="Nunito" pitchFamily="34" charset="-120"/>
               </a:rPr>
-              <a:t>Q3 sales missed consensus by 1.8%, Sandoz narrowed its 2026 growth guide to the low end of its range, and the shares fell 4.0% on 28 October. The fall is large for the size of the miss, since the higher margin guide points to earnings estimates 1% to 3% higher. The stock entered the release at a record 24.3x forward earnings.</a:t>
+              <a:t>Q3 sales missed consensus by 1.8%, Sandoz narrowed its 2026 growth guide to the low end of its range, and the shares fell 3.0% on 28 October. The fall is large for the size of the miss, since the higher margin guide points to earnings estimates 1% to 3% higher. The stock entered the release at 22.2x forward earnings, the highest since February.</a:t>
             </a:r>
             <a:endParaRPr lang="en-US" sz="870" dirty="0"/>
           </a:p>
@@ -2689,7 +2689,7 @@
                 <a:ea typeface="Nunito" pitchFamily="34" charset="-122"/>
                 <a:cs typeface="Nunito" pitchFamily="34" charset="-120"/>
               </a:rPr>
-              <a:t>We stay positive on Sandoz and keep the position. We underwrite consensus forward EPS of USD 4.08, 27% above a year ago, carried by the biosimilar mix and the higher margin guide. The debate has moved from growth to supply: biosimilar capacity stays tight until 2027 and the German market is unsettled. At 23.3x, the valuation leaves little room for further sales misses, and we expect the shares to follow earnings upgrades from here. The next test is the full-year results in March 2027, with the first 2027 guidance.</a:t>
+              <a:t>We stay positive on Sandoz and keep the position. We underwrite consensus forward EPS of USD 4.45, 16% above a year ago, carried by the biosimilar mix and the higher margin guide. The debate has moved from growth to supply: biosimilar capacity stays tight until 2027 and the German market is unsettled. At 21.6x, the valuation leaves little room for further sales misses, and we expect the shares to follow earnings upgrades from here. The next test is the full-year results in March 2027, with the first 2027 guidance.</a:t>
             </a:r>
             <a:endParaRPr lang="en-US" sz="870" dirty="0"/>
           </a:p>
@@ -3194,7 +3194,7 @@
                 <a:ea typeface="Nunito" pitchFamily="34" charset="-122"/>
                 <a:cs typeface="Nunito" pitchFamily="34" charset="-120"/>
               </a:rPr>
-              <a:t>Sales were 1.8% below consensus, with biosimilars 2% short and generics 1.8% short, and the shares fell 4.0% on 28 October. The move is large for a sales miss of this size combined with a higher margin guide, so surprise and reaction diverge in degree. The confirmed drivers are the narrowed sales guide, now at the lower end of the earlier range, and the shortfall in European biosimilar supply. We think positioning explains the rest: the shares closed at a record CHF 82.36 two days before the release, up 23% since the H1 results, on 24.5x forward earnings.</a:t>
+              <a:t>Sales were 1.8% below consensus, with biosimilars 2% short and generics 1.8% short, and the shares fell 3.0% on 28 October. The move is large for a sales miss of this size combined with a higher margin guide, so surprise and reaction diverge in degree. The confirmed drivers are the narrowed sales guide, now at the lower end of the earlier range, and the shortfall in European biosimilar supply. We think positioning explains the rest: the shares closed at a record CHF 82.36 two days before the release, up 24% since the H1 results, on 22.4x forward earnings.</a:t>
             </a:r>
             <a:endParaRPr lang="en-US" sz="870" dirty="0"/>
           </a:p>
@@ -3475,7 +3475,7 @@
                 <a:ea typeface="Nunito" pitchFamily="34" charset="-122"/>
                 <a:cs typeface="Nunito" pitchFamily="34" charset="-120"/>
               </a:rPr>
-              <a:t>Over 12 months the share price rose 58% while consensus forward EPS rose 27% in dollars, so most of the gain came from the multiple. Since the H1 results on 5 August the price is up 23% and EPS in francs 4%, taking the forward P/E from 19.8x to a record 24.5x on 26 October. It now stands at 23.3x, 38% above the 16.9x average since the 2023 listing and above the 21.0x one-year average. The price is 17% above its 40-week average of CHF 67.5. A 10% upgrade at today’s price would bring the multiple to 21.2x.</a:t>
+              <a:t>Over 12 months the share price rose 60% while consensus forward EPS rose 16% in dollars, so most of the gain came from the multiple. Since the H1 results on 5 August the price is up 24% and EPS in francs 5%, taking the forward P/E from 18.3x to 22.4x on 26 October. It now stands at 21.6x, 39% above the 15.5x average since the 2023 listing and above the 19.4x one-year average. The price is 18% above its 40-week average of CHF 67.5. A 10% upgrade at today’s price would bring the multiple to 19.6x.</a:t>
             </a:r>
             <a:endParaRPr lang="en-US" sz="870" dirty="0"/>
           </a:p>

</xml_diff>